<commit_message>
rework presentation pdf & pptx
</commit_message>
<xml_diff>
--- a/unet_inference_240426.pptx
+++ b/unet_inference_240426.pptx
@@ -32,9 +32,9 @@
     <p:sldId id="283" r:id="rId23"/>
     <p:sldId id="287" r:id="rId24"/>
     <p:sldId id="288" r:id="rId25"/>
-    <p:sldId id="284" r:id="rId26"/>
-    <p:sldId id="292" r:id="rId27"/>
-    <p:sldId id="293" r:id="rId28"/>
+    <p:sldId id="292" r:id="rId26"/>
+    <p:sldId id="293" r:id="rId27"/>
+    <p:sldId id="284" r:id="rId28"/>
     <p:sldId id="291" r:id="rId29"/>
     <p:sldId id="269" r:id="rId30"/>
   </p:sldIdLst>
@@ -13078,8 +13078,8 @@
         </p:nvSpPr>
         <p:spPr>
           <a:xfrm>
-            <a:off x="960000" y="719334"/>
-            <a:ext cx="4621325" cy="1347469"/>
+            <a:off x="342902" y="719334"/>
+            <a:ext cx="5753098" cy="1347469"/>
           </a:xfrm>
           <a:prstGeom prst="rect">
             <a:avLst/>
@@ -13117,8 +13117,8 @@
         </p:nvSpPr>
         <p:spPr>
           <a:xfrm>
-            <a:off x="6378447" y="714715"/>
-            <a:ext cx="4621325" cy="1347469"/>
+            <a:off x="6096000" y="714715"/>
+            <a:ext cx="5753099" cy="1347469"/>
           </a:xfrm>
           <a:prstGeom prst="rect">
             <a:avLst/>
@@ -13392,28 +13392,28 @@
       </p:sp>
       <p:pic>
         <p:nvPicPr>
-          <p:cNvPr id="2" name="Рисунок 1"/>
+          <p:cNvPr id="3" name="Рисунок 2">
+            <a:extLst>
+              <a:ext uri="{FF2B5EF4-FFF2-40B4-BE49-F238E27FC236}">
+                <a16:creationId xmlns:a16="http://schemas.microsoft.com/office/drawing/2014/main" id="{6485D845-DF70-0C3D-B60C-DCFC937D5EF9}"/>
+              </a:ext>
+            </a:extLst>
+          </p:cNvPr>
           <p:cNvPicPr>
             <a:picLocks noChangeAspect="1"/>
           </p:cNvPicPr>
           <p:nvPr/>
         </p:nvPicPr>
         <p:blipFill>
-          <a:blip r:embed="rId3">
-            <a:extLst>
-              <a:ext uri="{28A0092B-C50C-407E-A947-70E740481C1C}">
-                <a14:useLocalDpi xmlns:a14="http://schemas.microsoft.com/office/drawing/2010/main" val="0"/>
-              </a:ext>
-            </a:extLst>
-          </a:blip>
+          <a:blip r:embed="rId3"/>
           <a:stretch>
             <a:fillRect/>
           </a:stretch>
         </p:blipFill>
         <p:spPr>
           <a:xfrm>
-            <a:off x="6096000" y="1889760"/>
-            <a:ext cx="4903772" cy="3801801"/>
+            <a:off x="571100" y="1905017"/>
+            <a:ext cx="5296701" cy="3810636"/>
           </a:xfrm>
           <a:prstGeom prst="rect">
             <a:avLst/>
@@ -13422,28 +13422,28 @@
       </p:pic>
       <p:pic>
         <p:nvPicPr>
-          <p:cNvPr id="4" name="Рисунок 3"/>
+          <p:cNvPr id="7" name="Рисунок 6">
+            <a:extLst>
+              <a:ext uri="{FF2B5EF4-FFF2-40B4-BE49-F238E27FC236}">
+                <a16:creationId xmlns:a16="http://schemas.microsoft.com/office/drawing/2014/main" id="{76E595DB-DF5B-ED87-D77C-C2961E0276F8}"/>
+              </a:ext>
+            </a:extLst>
+          </p:cNvPr>
           <p:cNvPicPr>
             <a:picLocks noChangeAspect="1"/>
           </p:cNvPicPr>
           <p:nvPr/>
         </p:nvPicPr>
         <p:blipFill>
-          <a:blip r:embed="rId4">
-            <a:extLst>
-              <a:ext uri="{28A0092B-C50C-407E-A947-70E740481C1C}">
-                <a14:useLocalDpi xmlns:a14="http://schemas.microsoft.com/office/drawing/2010/main" val="0"/>
-              </a:ext>
-            </a:extLst>
-          </a:blip>
+          <a:blip r:embed="rId4"/>
           <a:stretch>
             <a:fillRect/>
           </a:stretch>
         </p:blipFill>
         <p:spPr>
           <a:xfrm>
-            <a:off x="986459" y="2049780"/>
-            <a:ext cx="4700799" cy="3606829"/>
+            <a:off x="6190847" y="1781175"/>
+            <a:ext cx="5336711" cy="4058303"/>
           </a:xfrm>
           <a:prstGeom prst="rect">
             <a:avLst/>
@@ -13534,28 +13534,28 @@
       </p:sp>
       <p:pic>
         <p:nvPicPr>
-          <p:cNvPr id="4" name="Рисунок 3"/>
+          <p:cNvPr id="5" name="Рисунок 4">
+            <a:extLst>
+              <a:ext uri="{FF2B5EF4-FFF2-40B4-BE49-F238E27FC236}">
+                <a16:creationId xmlns:a16="http://schemas.microsoft.com/office/drawing/2014/main" id="{E66EE6BB-996F-FA43-4837-A6B998584782}"/>
+              </a:ext>
+            </a:extLst>
+          </p:cNvPr>
           <p:cNvPicPr>
             <a:picLocks noChangeAspect="1"/>
           </p:cNvPicPr>
           <p:nvPr/>
         </p:nvPicPr>
         <p:blipFill>
-          <a:blip r:embed="rId3">
-            <a:extLst>
-              <a:ext uri="{28A0092B-C50C-407E-A947-70E740481C1C}">
-                <a14:useLocalDpi xmlns:a14="http://schemas.microsoft.com/office/drawing/2010/main" val="0"/>
-              </a:ext>
-            </a:extLst>
-          </a:blip>
+          <a:blip r:embed="rId3"/>
           <a:stretch>
             <a:fillRect/>
           </a:stretch>
         </p:blipFill>
         <p:spPr>
           <a:xfrm>
-            <a:off x="2787015" y="1815343"/>
-            <a:ext cx="6115050" cy="4495800"/>
+            <a:off x="2638207" y="1870776"/>
+            <a:ext cx="6439335" cy="4519350"/>
           </a:xfrm>
           <a:prstGeom prst="rect">
             <a:avLst/>
@@ -13895,13 +13895,13 @@
               <a:rPr lang="ru-RU" sz="2000" dirty="0">
                 <a:latin typeface="Maven Pro" panose="00000500000000000000" pitchFamily="2" charset="0"/>
               </a:rPr>
-              <a:t>модель </a:t>
+              <a:t>модель в </a:t>
             </a:r>
             <a:r>
               <a:rPr lang="en-US" sz="2000" dirty="0">
                 <a:latin typeface="Maven Pro" panose="00000500000000000000" pitchFamily="2" charset="0"/>
               </a:rPr>
-              <a:t>FP16/BF16 </a:t>
+              <a:t>BF16 </a:t>
             </a:r>
             <a:r>
               <a:rPr lang="ru-RU" sz="2000" dirty="0">
@@ -14496,28 +14496,28 @@
       </p:sp>
       <p:pic>
         <p:nvPicPr>
-          <p:cNvPr id="6" name="Рисунок 5"/>
+          <p:cNvPr id="3" name="Рисунок 2">
+            <a:extLst>
+              <a:ext uri="{FF2B5EF4-FFF2-40B4-BE49-F238E27FC236}">
+                <a16:creationId xmlns:a16="http://schemas.microsoft.com/office/drawing/2014/main" id="{F9F5F3DF-7781-180D-D71B-2772BDED0F55}"/>
+              </a:ext>
+            </a:extLst>
+          </p:cNvPr>
           <p:cNvPicPr>
             <a:picLocks noChangeAspect="1"/>
           </p:cNvPicPr>
           <p:nvPr/>
         </p:nvPicPr>
         <p:blipFill>
-          <a:blip r:embed="rId3">
-            <a:extLst>
-              <a:ext uri="{28A0092B-C50C-407E-A947-70E740481C1C}">
-                <a14:useLocalDpi xmlns:a14="http://schemas.microsoft.com/office/drawing/2010/main" val="0"/>
-              </a:ext>
-            </a:extLst>
-          </a:blip>
+          <a:blip r:embed="rId3"/>
           <a:stretch>
             <a:fillRect/>
           </a:stretch>
         </p:blipFill>
         <p:spPr>
           <a:xfrm>
-            <a:off x="6215915" y="2062184"/>
-            <a:ext cx="4946387" cy="3606165"/>
+            <a:off x="602702" y="1674201"/>
+            <a:ext cx="5335919" cy="4070348"/>
           </a:xfrm>
           <a:prstGeom prst="rect">
             <a:avLst/>
@@ -14526,28 +14526,28 @@
       </p:pic>
       <p:pic>
         <p:nvPicPr>
-          <p:cNvPr id="7" name="Рисунок 6"/>
+          <p:cNvPr id="8" name="Рисунок 7">
+            <a:extLst>
+              <a:ext uri="{FF2B5EF4-FFF2-40B4-BE49-F238E27FC236}">
+                <a16:creationId xmlns:a16="http://schemas.microsoft.com/office/drawing/2014/main" id="{4C506C0A-004E-C9C2-7301-90AD6F5AA35F}"/>
+              </a:ext>
+            </a:extLst>
+          </p:cNvPr>
           <p:cNvPicPr>
             <a:picLocks noChangeAspect="1"/>
           </p:cNvPicPr>
           <p:nvPr/>
         </p:nvPicPr>
         <p:blipFill>
-          <a:blip r:embed="rId4">
-            <a:extLst>
-              <a:ext uri="{28A0092B-C50C-407E-A947-70E740481C1C}">
-                <a14:useLocalDpi xmlns:a14="http://schemas.microsoft.com/office/drawing/2010/main" val="0"/>
-              </a:ext>
-            </a:extLst>
-          </a:blip>
+          <a:blip r:embed="rId4"/>
           <a:stretch>
             <a:fillRect/>
           </a:stretch>
         </p:blipFill>
         <p:spPr>
           <a:xfrm>
-            <a:off x="960000" y="2062184"/>
-            <a:ext cx="4719509" cy="3485176"/>
+            <a:off x="6155778" y="1781174"/>
+            <a:ext cx="5433520" cy="3963375"/>
           </a:xfrm>
           <a:prstGeom prst="rect">
             <a:avLst/>
@@ -15437,9 +15437,27 @@
               </a:rPr>
               <a:t>Слои не меняются</a:t>
             </a:r>
-            <a:endParaRPr lang="en-US" sz="2000" dirty="0">
-              <a:latin typeface="Maven Pro Medium" panose="00000600000000000000" pitchFamily="2" charset="0"/>
-            </a:endParaRPr>
+          </a:p>
+          <a:p>
+            <a:pPr marL="228594" indent="-228594">
+              <a:lnSpc>
+                <a:spcPct val="150000"/>
+              </a:lnSpc>
+              <a:buFont typeface="Arial"/>
+              <a:buChar char="•"/>
+            </a:pPr>
+            <a:r>
+              <a:rPr lang="ru-RU" sz="2000" dirty="0">
+                <a:latin typeface="Maven Pro Medium" panose="00000600000000000000" pitchFamily="2" charset="0"/>
+              </a:rPr>
+              <a:t>Используем </a:t>
+            </a:r>
+            <a:r>
+              <a:rPr lang="en-US" sz="2000" dirty="0">
+                <a:latin typeface="Maven Pro Medium" panose="00000600000000000000" pitchFamily="2" charset="0"/>
+              </a:rPr>
+              <a:t>torch.nn.utils.l1_unstructed</a:t>
+            </a:r>
           </a:p>
           <a:p>
             <a:pPr marL="228594" indent="-228594">
@@ -16373,7 +16391,7 @@
               <a:rPr lang="en-US" sz="4000" dirty="0" err="1">
                 <a:latin typeface="Maven Pro Medium" panose="00000600000000000000" pitchFamily="2" charset="0"/>
               </a:rPr>
-              <a:t>IoU</a:t>
+              <a:t>mIoU</a:t>
             </a:r>
             <a:r>
               <a:rPr lang="en-US" sz="4000" dirty="0">
@@ -16613,7 +16631,19 @@
               <a:rPr lang="en-US" sz="1800" b="1" dirty="0">
                 <a:latin typeface="Maven Pro" panose="00000500000000000000" pitchFamily="2" charset="0"/>
               </a:rPr>
-              <a:t> baseline = 0.4519</a:t>
+              <a:t> baseline = 0.4</a:t>
+            </a:r>
+            <a:r>
+              <a:rPr lang="ru-RU" sz="1800" b="1" dirty="0">
+                <a:latin typeface="Maven Pro" panose="00000500000000000000" pitchFamily="2" charset="0"/>
+              </a:rPr>
+              <a:t>8</a:t>
+            </a:r>
+            <a:r>
+              <a:rPr lang="en-US" sz="1800" b="1" dirty="0">
+                <a:latin typeface="Maven Pro" panose="00000500000000000000" pitchFamily="2" charset="0"/>
+              </a:rPr>
+              <a:t>19</a:t>
             </a:r>
           </a:p>
           <a:p>
@@ -16979,34 +17009,10 @@
               <a:buChar char="•"/>
             </a:pPr>
             <a:r>
-              <a:rPr lang="en-US" sz="2000" dirty="0">
-                <a:latin typeface="Maven Pro Medium" panose="00000600000000000000"/>
-              </a:rPr>
-              <a:t>Aggressive </a:t>
-            </a:r>
-            <a:r>
-              <a:rPr lang="en-US" sz="2000" dirty="0" err="1">
-                <a:latin typeface="Maven Pro Medium" panose="00000600000000000000"/>
-              </a:rPr>
-              <a:t>prining</a:t>
-            </a:r>
-            <a:r>
-              <a:rPr lang="en-US" sz="2000" dirty="0">
-                <a:latin typeface="Maven Pro Medium" panose="00000600000000000000"/>
-              </a:rPr>
-              <a:t> </a:t>
-            </a:r>
-            <a:r>
               <a:rPr lang="ru-RU" sz="2000" dirty="0">
                 <a:latin typeface="Maven Pro Medium" panose="00000600000000000000"/>
               </a:rPr>
-              <a:t>с помощью</a:t>
-            </a:r>
-            <a:r>
-              <a:rPr lang="ru-RU" sz="2000" dirty="0">
-                <a:latin typeface="Maven Pro" panose="00000500000000000000" pitchFamily="2" charset="0"/>
-              </a:rPr>
-              <a:t> </a:t>
+              <a:t>Использовали </a:t>
             </a:r>
             <a:r>
               <a:rPr lang="en-US" sz="2000" dirty="0">
@@ -17459,7 +17465,7 @@
               <a:rPr lang="en-US" sz="4000" dirty="0" err="1">
                 <a:latin typeface="Maven Pro Medium" panose="00000600000000000000" pitchFamily="2" charset="0"/>
               </a:rPr>
-              <a:t>IoU</a:t>
+              <a:t>mIoU</a:t>
             </a:r>
             <a:r>
               <a:rPr lang="en-US" sz="4000" dirty="0">
@@ -18072,7 +18078,7 @@
               <a:rPr lang="en-US" sz="4000" dirty="0" err="1">
                 <a:latin typeface="Maven Pro Medium" panose="00000600000000000000" pitchFamily="2" charset="0"/>
               </a:rPr>
-              <a:t>IoU</a:t>
+              <a:t>mIoU</a:t>
             </a:r>
             <a:r>
               <a:rPr lang="en-US" sz="4000" dirty="0">
@@ -18385,392 +18391,6 @@
 </file>
 
 <file path=ppt/slides/slide25.xml><?xml version="1.0" encoding="utf-8"?>
-<p:sld xmlns:a="http://schemas.openxmlformats.org/drawingml/2006/main" xmlns:r="http://schemas.openxmlformats.org/officeDocument/2006/relationships" xmlns:p="http://schemas.openxmlformats.org/presentationml/2006/main">
-  <p:cSld>
-    <p:spTree>
-      <p:nvGrpSpPr>
-        <p:cNvPr id="1" name=""/>
-        <p:cNvGrpSpPr/>
-        <p:nvPr/>
-      </p:nvGrpSpPr>
-      <p:grpSpPr>
-        <a:xfrm>
-          <a:off x="0" y="0"/>
-          <a:ext cx="0" cy="0"/>
-          <a:chOff x="0" y="0"/>
-          <a:chExt cx="0" cy="0"/>
-        </a:xfrm>
-      </p:grpSpPr>
-      <p:sp>
-        <p:nvSpPr>
-          <p:cNvPr id="2" name="Заголовок 1"/>
-          <p:cNvSpPr>
-            <a:spLocks noGrp="1"/>
-          </p:cNvSpPr>
-          <p:nvPr>
-            <p:ph type="title"/>
-          </p:nvPr>
-        </p:nvSpPr>
-        <p:spPr>
-          <a:xfrm>
-            <a:off x="960000" y="719332"/>
-            <a:ext cx="10272000" cy="1527253"/>
-          </a:xfrm>
-        </p:spPr>
-        <p:txBody>
-          <a:bodyPr/>
-          <a:lstStyle/>
-          <a:p>
-            <a:pPr algn="ctr"/>
-            <a:r>
-              <a:rPr lang="en-US" dirty="0">
-                <a:latin typeface="Maven Pro Medium" panose="00000600000000000000" pitchFamily="2" charset="0"/>
-              </a:rPr>
-              <a:t>2:4 semi structured pruning + </a:t>
-            </a:r>
-            <a:r>
-              <a:rPr lang="en-US" dirty="0" err="1">
-                <a:latin typeface="Maven Pro Medium" panose="00000600000000000000" pitchFamily="2" charset="0"/>
-              </a:rPr>
-              <a:t>finetuning</a:t>
-            </a:r>
-            <a:endParaRPr lang="ru-RU" dirty="0"/>
-          </a:p>
-        </p:txBody>
-      </p:sp>
-      <p:sp>
-        <p:nvSpPr>
-          <p:cNvPr id="3" name="Google Shape;275;p32"/>
-          <p:cNvSpPr txBox="1">
-            <a:spLocks/>
-          </p:cNvSpPr>
-          <p:nvPr/>
-        </p:nvSpPr>
-        <p:spPr>
-          <a:xfrm>
-            <a:off x="1071456" y="1808435"/>
-            <a:ext cx="10049088" cy="4128275"/>
-          </a:xfrm>
-          <a:prstGeom prst="rect">
-            <a:avLst/>
-          </a:prstGeom>
-        </p:spPr>
-        <p:txBody>
-          <a:bodyPr spcFirstLastPara="1" vert="horz" wrap="square" lIns="121900" tIns="121900" rIns="121900" bIns="121900" rtlCol="0" anchor="t" anchorCtr="0">
-            <a:noAutofit/>
-          </a:bodyPr>
-          <a:lstStyle>
-            <a:lvl1pPr marL="228600" indent="-228600" algn="l" defTabSz="914400" rtl="0" eaLnBrk="1" latinLnBrk="0" hangingPunct="1">
-              <a:lnSpc>
-                <a:spcPct val="90000"/>
-              </a:lnSpc>
-              <a:spcBef>
-                <a:spcPts val="1000"/>
-              </a:spcBef>
-              <a:buFont typeface="Arial" panose="020B0604020202020204" pitchFamily="34" charset="0"/>
-              <a:buChar char="•"/>
-              <a:defRPr sz="2800" kern="1200">
-                <a:solidFill>
-                  <a:schemeClr val="tx1"/>
-                </a:solidFill>
-                <a:latin typeface="+mn-lt"/>
-                <a:ea typeface="+mn-ea"/>
-                <a:cs typeface="+mn-cs"/>
-              </a:defRPr>
-            </a:lvl1pPr>
-            <a:lvl2pPr marL="685800" indent="-228600" algn="l" defTabSz="914400" rtl="0" eaLnBrk="1" latinLnBrk="0" hangingPunct="1">
-              <a:lnSpc>
-                <a:spcPct val="90000"/>
-              </a:lnSpc>
-              <a:spcBef>
-                <a:spcPts val="500"/>
-              </a:spcBef>
-              <a:buFont typeface="Arial" panose="020B0604020202020204" pitchFamily="34" charset="0"/>
-              <a:buChar char="•"/>
-              <a:defRPr sz="2400" kern="1200">
-                <a:solidFill>
-                  <a:schemeClr val="tx1"/>
-                </a:solidFill>
-                <a:latin typeface="+mn-lt"/>
-                <a:ea typeface="+mn-ea"/>
-                <a:cs typeface="+mn-cs"/>
-              </a:defRPr>
-            </a:lvl2pPr>
-            <a:lvl3pPr marL="1143000" indent="-228600" algn="l" defTabSz="914400" rtl="0" eaLnBrk="1" latinLnBrk="0" hangingPunct="1">
-              <a:lnSpc>
-                <a:spcPct val="90000"/>
-              </a:lnSpc>
-              <a:spcBef>
-                <a:spcPts val="500"/>
-              </a:spcBef>
-              <a:buFont typeface="Arial" panose="020B0604020202020204" pitchFamily="34" charset="0"/>
-              <a:buChar char="•"/>
-              <a:defRPr sz="2000" kern="1200">
-                <a:solidFill>
-                  <a:schemeClr val="tx1"/>
-                </a:solidFill>
-                <a:latin typeface="+mn-lt"/>
-                <a:ea typeface="+mn-ea"/>
-                <a:cs typeface="+mn-cs"/>
-              </a:defRPr>
-            </a:lvl3pPr>
-            <a:lvl4pPr marL="1600200" indent="-228600" algn="l" defTabSz="914400" rtl="0" eaLnBrk="1" latinLnBrk="0" hangingPunct="1">
-              <a:lnSpc>
-                <a:spcPct val="90000"/>
-              </a:lnSpc>
-              <a:spcBef>
-                <a:spcPts val="500"/>
-              </a:spcBef>
-              <a:buFont typeface="Arial" panose="020B0604020202020204" pitchFamily="34" charset="0"/>
-              <a:buChar char="•"/>
-              <a:defRPr sz="1800" kern="1200">
-                <a:solidFill>
-                  <a:schemeClr val="tx1"/>
-                </a:solidFill>
-                <a:latin typeface="+mn-lt"/>
-                <a:ea typeface="+mn-ea"/>
-                <a:cs typeface="+mn-cs"/>
-              </a:defRPr>
-            </a:lvl4pPr>
-            <a:lvl5pPr marL="2057400" indent="-228600" algn="l" defTabSz="914400" rtl="0" eaLnBrk="1" latinLnBrk="0" hangingPunct="1">
-              <a:lnSpc>
-                <a:spcPct val="90000"/>
-              </a:lnSpc>
-              <a:spcBef>
-                <a:spcPts val="500"/>
-              </a:spcBef>
-              <a:buFont typeface="Arial" panose="020B0604020202020204" pitchFamily="34" charset="0"/>
-              <a:buChar char="•"/>
-              <a:defRPr sz="1800" kern="1200">
-                <a:solidFill>
-                  <a:schemeClr val="tx1"/>
-                </a:solidFill>
-                <a:latin typeface="+mn-lt"/>
-                <a:ea typeface="+mn-ea"/>
-                <a:cs typeface="+mn-cs"/>
-              </a:defRPr>
-            </a:lvl5pPr>
-            <a:lvl6pPr marL="2514600" indent="-228600" algn="l" defTabSz="914400" rtl="0" eaLnBrk="1" latinLnBrk="0" hangingPunct="1">
-              <a:lnSpc>
-                <a:spcPct val="90000"/>
-              </a:lnSpc>
-              <a:spcBef>
-                <a:spcPts val="500"/>
-              </a:spcBef>
-              <a:buFont typeface="Arial" panose="020B0604020202020204" pitchFamily="34" charset="0"/>
-              <a:buChar char="•"/>
-              <a:defRPr sz="1800" kern="1200">
-                <a:solidFill>
-                  <a:schemeClr val="tx1"/>
-                </a:solidFill>
-                <a:latin typeface="+mn-lt"/>
-                <a:ea typeface="+mn-ea"/>
-                <a:cs typeface="+mn-cs"/>
-              </a:defRPr>
-            </a:lvl6pPr>
-            <a:lvl7pPr marL="2971800" indent="-228600" algn="l" defTabSz="914400" rtl="0" eaLnBrk="1" latinLnBrk="0" hangingPunct="1">
-              <a:lnSpc>
-                <a:spcPct val="90000"/>
-              </a:lnSpc>
-              <a:spcBef>
-                <a:spcPts val="500"/>
-              </a:spcBef>
-              <a:buFont typeface="Arial" panose="020B0604020202020204" pitchFamily="34" charset="0"/>
-              <a:buChar char="•"/>
-              <a:defRPr sz="1800" kern="1200">
-                <a:solidFill>
-                  <a:schemeClr val="tx1"/>
-                </a:solidFill>
-                <a:latin typeface="+mn-lt"/>
-                <a:ea typeface="+mn-ea"/>
-                <a:cs typeface="+mn-cs"/>
-              </a:defRPr>
-            </a:lvl7pPr>
-            <a:lvl8pPr marL="3429000" indent="-228600" algn="l" defTabSz="914400" rtl="0" eaLnBrk="1" latinLnBrk="0" hangingPunct="1">
-              <a:lnSpc>
-                <a:spcPct val="90000"/>
-              </a:lnSpc>
-              <a:spcBef>
-                <a:spcPts val="500"/>
-              </a:spcBef>
-              <a:buFont typeface="Arial" panose="020B0604020202020204" pitchFamily="34" charset="0"/>
-              <a:buChar char="•"/>
-              <a:defRPr sz="1800" kern="1200">
-                <a:solidFill>
-                  <a:schemeClr val="tx1"/>
-                </a:solidFill>
-                <a:latin typeface="+mn-lt"/>
-                <a:ea typeface="+mn-ea"/>
-                <a:cs typeface="+mn-cs"/>
-              </a:defRPr>
-            </a:lvl8pPr>
-            <a:lvl9pPr marL="3886200" indent="-228600" algn="l" defTabSz="914400" rtl="0" eaLnBrk="1" latinLnBrk="0" hangingPunct="1">
-              <a:lnSpc>
-                <a:spcPct val="90000"/>
-              </a:lnSpc>
-              <a:spcBef>
-                <a:spcPts val="500"/>
-              </a:spcBef>
-              <a:buFont typeface="Arial" panose="020B0604020202020204" pitchFamily="34" charset="0"/>
-              <a:buChar char="•"/>
-              <a:defRPr sz="1800" kern="1200">
-                <a:solidFill>
-                  <a:schemeClr val="tx1"/>
-                </a:solidFill>
-                <a:latin typeface="+mn-lt"/>
-                <a:ea typeface="+mn-ea"/>
-                <a:cs typeface="+mn-cs"/>
-              </a:defRPr>
-            </a:lvl9pPr>
-          </a:lstStyle>
-          <a:p>
-            <a:pPr marL="0" indent="0">
-              <a:buNone/>
-            </a:pPr>
-            <a:r>
-              <a:rPr lang="ru-RU" sz="2000" b="1" dirty="0"/>
-              <a:t>Ускорения не достичь</a:t>
-            </a:r>
-          </a:p>
-          <a:p>
-            <a:pPr marL="0" indent="0">
-              <a:buNone/>
-            </a:pPr>
-            <a:r>
-              <a:rPr lang="ru-RU" sz="2000" dirty="0"/>
-              <a:t>Модель:</a:t>
-            </a:r>
-          </a:p>
-          <a:p>
-            <a:r>
-              <a:rPr lang="ru-RU" sz="2000" dirty="0"/>
-              <a:t>почти полностью состоит из Conv2d</a:t>
-            </a:r>
-          </a:p>
-          <a:p>
-            <a:r>
-              <a:rPr lang="ru-RU" sz="2000" dirty="0"/>
-              <a:t>не содержит тяжёлых </a:t>
-            </a:r>
-            <a:r>
-              <a:rPr lang="ru-RU" sz="2000" dirty="0" err="1"/>
-              <a:t>Linear</a:t>
-            </a:r>
-            <a:r>
-              <a:rPr lang="ru-RU" sz="2000" dirty="0"/>
-              <a:t>-слоёв</a:t>
-            </a:r>
-          </a:p>
-          <a:p>
-            <a:pPr marL="0" indent="0">
-              <a:buNone/>
-            </a:pPr>
-            <a:r>
-              <a:rPr lang="ru-RU" sz="2000" dirty="0"/>
-              <a:t>2:4 </a:t>
-            </a:r>
-            <a:r>
-              <a:rPr lang="ru-RU" sz="2000" dirty="0" err="1"/>
-              <a:t>sparsity</a:t>
-            </a:r>
-            <a:r>
-              <a:rPr lang="ru-RU" sz="2000" dirty="0"/>
-              <a:t> в </a:t>
-            </a:r>
-            <a:r>
-              <a:rPr lang="ru-RU" sz="2000" dirty="0" err="1"/>
-              <a:t>PyTorch</a:t>
-            </a:r>
-            <a:r>
-              <a:rPr lang="ru-RU" sz="2000" dirty="0"/>
-              <a:t>:</a:t>
-            </a:r>
-          </a:p>
-          <a:p>
-            <a:r>
-              <a:rPr lang="ru-RU" sz="2000" dirty="0"/>
-              <a:t>ускоряется через </a:t>
-            </a:r>
-            <a:r>
-              <a:rPr lang="ru-RU" sz="2000" dirty="0" err="1"/>
-              <a:t>sparse</a:t>
-            </a:r>
-            <a:r>
-              <a:rPr lang="ru-RU" sz="2000" dirty="0"/>
-              <a:t> </a:t>
-            </a:r>
-            <a:r>
-              <a:rPr lang="ru-RU" sz="2000" dirty="0" err="1"/>
-              <a:t>matmul</a:t>
-            </a:r>
-            <a:r>
-              <a:rPr lang="ru-RU" sz="2000" dirty="0"/>
-              <a:t> (GEMM)</a:t>
-            </a:r>
-          </a:p>
-          <a:p>
-            <a:r>
-              <a:rPr lang="ru-RU" sz="2000" dirty="0"/>
-              <a:t>эффективно работает для </a:t>
-            </a:r>
-            <a:r>
-              <a:rPr lang="ru-RU" sz="2000" dirty="0" err="1"/>
-              <a:t>nn.Linear</a:t>
-            </a:r>
-            <a:endParaRPr lang="ru-RU" sz="2000" dirty="0"/>
-          </a:p>
-          <a:p>
-            <a:r>
-              <a:rPr lang="ru-RU" sz="2000" dirty="0"/>
-              <a:t>не даёт ускорения для Conv2d (т.к. Conv2d + 2:4 </a:t>
-            </a:r>
-            <a:r>
-              <a:rPr lang="ru-RU" sz="2000" dirty="0" err="1"/>
-              <a:t>mask</a:t>
-            </a:r>
-            <a:r>
-              <a:rPr lang="ru-RU" sz="2000" dirty="0"/>
-              <a:t> -&gt; вычисляется как обычный </a:t>
-            </a:r>
-            <a:r>
-              <a:rPr lang="ru-RU" sz="2000" dirty="0" err="1"/>
-              <a:t>dense</a:t>
-            </a:r>
-            <a:r>
-              <a:rPr lang="ru-RU" sz="2000" dirty="0"/>
-              <a:t> </a:t>
-            </a:r>
-            <a:r>
-              <a:rPr lang="ru-RU" sz="2000" dirty="0" err="1"/>
-              <a:t>conv</a:t>
-            </a:r>
-            <a:r>
-              <a:rPr lang="ru-RU" sz="2000" dirty="0"/>
-              <a:t> с нулями)</a:t>
-            </a:r>
-          </a:p>
-          <a:p>
-            <a:pPr marL="0" indent="0">
-              <a:buNone/>
-            </a:pPr>
-            <a:endParaRPr lang="ru-RU" sz="2000" dirty="0"/>
-          </a:p>
-        </p:txBody>
-      </p:sp>
-    </p:spTree>
-    <p:extLst>
-      <p:ext uri="{BB962C8B-B14F-4D97-AF65-F5344CB8AC3E}">
-        <p14:creationId xmlns:p14="http://schemas.microsoft.com/office/powerpoint/2010/main" val="325205390"/>
-      </p:ext>
-    </p:extLst>
-  </p:cSld>
-  <p:clrMapOvr>
-    <a:masterClrMapping/>
-  </p:clrMapOvr>
-</p:sld>
-</file>
-
-<file path=ppt/slides/slide26.xml><?xml version="1.0" encoding="utf-8"?>
 <p:sld xmlns:a="http://schemas.openxmlformats.org/drawingml/2006/main" xmlns:r="http://schemas.openxmlformats.org/officeDocument/2006/relationships" xmlns:p="http://schemas.openxmlformats.org/presentationml/2006/main">
   <p:cSld>
     <p:spTree>
@@ -19196,7 +18816,7 @@
 </p:sld>
 </file>
 
-<file path=ppt/slides/slide27.xml><?xml version="1.0" encoding="utf-8"?>
+<file path=ppt/slides/slide26.xml><?xml version="1.0" encoding="utf-8"?>
 <p:sld xmlns:a="http://schemas.openxmlformats.org/drawingml/2006/main" xmlns:r="http://schemas.openxmlformats.org/officeDocument/2006/relationships" xmlns:p="http://schemas.openxmlformats.org/presentationml/2006/main">
   <p:cSld>
     <p:spTree>
@@ -19239,7 +18859,7 @@
           </a:prstGeom>
         </p:spPr>
         <p:txBody>
-          <a:bodyPr spcFirstLastPara="1" vert="horz" wrap="square" lIns="121900" tIns="121900" rIns="121900" bIns="121900" rtlCol="0" anchor="ctr" anchorCtr="0">
+          <a:bodyPr spcFirstLastPara="1" vert="horz" wrap="square" lIns="121900" tIns="121900" rIns="121900" bIns="121900" numCol="2" rtlCol="0" anchor="ctr" anchorCtr="0">
             <a:noAutofit/>
           </a:bodyPr>
           <a:lstStyle/>
@@ -19249,8 +18869,13 @@
               <a:rPr lang="en" sz="4400" dirty="0">
                 <a:latin typeface="Maven Pro Medium" panose="00000600000000000000" pitchFamily="2" charset="0"/>
               </a:rPr>
-              <a:t>Baseline &amp; Torch compile</a:t>
-            </a:r>
+              <a:t>Throughput</a:t>
+            </a:r>
+            <a:br>
+              <a:rPr lang="en" sz="4400" dirty="0">
+                <a:latin typeface="Maven Pro Medium" panose="00000600000000000000" pitchFamily="2" charset="0"/>
+              </a:rPr>
+            </a:br>
             <a:br>
               <a:rPr lang="en" sz="4400" dirty="0">
                 <a:latin typeface="Maven Pro Medium" panose="00000600000000000000" pitchFamily="2" charset="0"/>
@@ -19287,8 +18912,38 @@
         </p:blipFill>
         <p:spPr>
           <a:xfrm>
-            <a:off x="2990416" y="1807962"/>
-            <a:ext cx="6211167" cy="4582164"/>
+            <a:off x="6126886" y="1905001"/>
+            <a:ext cx="5214578" cy="3846950"/>
+          </a:xfrm>
+          <a:prstGeom prst="rect">
+            <a:avLst/>
+          </a:prstGeom>
+        </p:spPr>
+      </p:pic>
+      <p:pic>
+        <p:nvPicPr>
+          <p:cNvPr id="4" name="Рисунок 3">
+            <a:extLst>
+              <a:ext uri="{FF2B5EF4-FFF2-40B4-BE49-F238E27FC236}">
+                <a16:creationId xmlns:a16="http://schemas.microsoft.com/office/drawing/2014/main" id="{B78FF8A2-6B28-852D-FDFC-9942AB1BBBE1}"/>
+              </a:ext>
+            </a:extLst>
+          </p:cNvPr>
+          <p:cNvPicPr>
+            <a:picLocks noChangeAspect="1"/>
+          </p:cNvPicPr>
+          <p:nvPr/>
+        </p:nvPicPr>
+        <p:blipFill>
+          <a:blip r:embed="rId4"/>
+          <a:stretch>
+            <a:fillRect/>
+          </a:stretch>
+        </p:blipFill>
+        <p:spPr>
+          <a:xfrm>
+            <a:off x="580808" y="2047874"/>
+            <a:ext cx="5277704" cy="3704077"/>
           </a:xfrm>
           <a:prstGeom prst="rect">
             <a:avLst/>
@@ -19299,6 +18954,392 @@
     <p:extLst>
       <p:ext uri="{BB962C8B-B14F-4D97-AF65-F5344CB8AC3E}">
         <p14:creationId xmlns:p14="http://schemas.microsoft.com/office/powerpoint/2010/main" val="3468337160"/>
+      </p:ext>
+    </p:extLst>
+  </p:cSld>
+  <p:clrMapOvr>
+    <a:masterClrMapping/>
+  </p:clrMapOvr>
+</p:sld>
+</file>
+
+<file path=ppt/slides/slide27.xml><?xml version="1.0" encoding="utf-8"?>
+<p:sld xmlns:a="http://schemas.openxmlformats.org/drawingml/2006/main" xmlns:r="http://schemas.openxmlformats.org/officeDocument/2006/relationships" xmlns:p="http://schemas.openxmlformats.org/presentationml/2006/main">
+  <p:cSld>
+    <p:spTree>
+      <p:nvGrpSpPr>
+        <p:cNvPr id="1" name=""/>
+        <p:cNvGrpSpPr/>
+        <p:nvPr/>
+      </p:nvGrpSpPr>
+      <p:grpSpPr>
+        <a:xfrm>
+          <a:off x="0" y="0"/>
+          <a:ext cx="0" cy="0"/>
+          <a:chOff x="0" y="0"/>
+          <a:chExt cx="0" cy="0"/>
+        </a:xfrm>
+      </p:grpSpPr>
+      <p:sp>
+        <p:nvSpPr>
+          <p:cNvPr id="2" name="Заголовок 1"/>
+          <p:cNvSpPr>
+            <a:spLocks noGrp="1"/>
+          </p:cNvSpPr>
+          <p:nvPr>
+            <p:ph type="title"/>
+          </p:nvPr>
+        </p:nvSpPr>
+        <p:spPr>
+          <a:xfrm>
+            <a:off x="960000" y="719332"/>
+            <a:ext cx="10272000" cy="1527253"/>
+          </a:xfrm>
+        </p:spPr>
+        <p:txBody>
+          <a:bodyPr/>
+          <a:lstStyle/>
+          <a:p>
+            <a:pPr algn="ctr"/>
+            <a:r>
+              <a:rPr lang="en-US" dirty="0">
+                <a:latin typeface="Maven Pro Medium" panose="00000600000000000000" pitchFamily="2" charset="0"/>
+              </a:rPr>
+              <a:t>2:4 semi structured pruning + </a:t>
+            </a:r>
+            <a:r>
+              <a:rPr lang="en-US" dirty="0" err="1">
+                <a:latin typeface="Maven Pro Medium" panose="00000600000000000000" pitchFamily="2" charset="0"/>
+              </a:rPr>
+              <a:t>finetuning</a:t>
+            </a:r>
+            <a:endParaRPr lang="ru-RU" dirty="0"/>
+          </a:p>
+        </p:txBody>
+      </p:sp>
+      <p:sp>
+        <p:nvSpPr>
+          <p:cNvPr id="3" name="Google Shape;275;p32"/>
+          <p:cNvSpPr txBox="1">
+            <a:spLocks/>
+          </p:cNvSpPr>
+          <p:nvPr/>
+        </p:nvSpPr>
+        <p:spPr>
+          <a:xfrm>
+            <a:off x="1071456" y="1808435"/>
+            <a:ext cx="10049088" cy="4128275"/>
+          </a:xfrm>
+          <a:prstGeom prst="rect">
+            <a:avLst/>
+          </a:prstGeom>
+        </p:spPr>
+        <p:txBody>
+          <a:bodyPr spcFirstLastPara="1" vert="horz" wrap="square" lIns="121900" tIns="121900" rIns="121900" bIns="121900" rtlCol="0" anchor="t" anchorCtr="0">
+            <a:noAutofit/>
+          </a:bodyPr>
+          <a:lstStyle>
+            <a:lvl1pPr marL="228600" indent="-228600" algn="l" defTabSz="914400" rtl="0" eaLnBrk="1" latinLnBrk="0" hangingPunct="1">
+              <a:lnSpc>
+                <a:spcPct val="90000"/>
+              </a:lnSpc>
+              <a:spcBef>
+                <a:spcPts val="1000"/>
+              </a:spcBef>
+              <a:buFont typeface="Arial" panose="020B0604020202020204" pitchFamily="34" charset="0"/>
+              <a:buChar char="•"/>
+              <a:defRPr sz="2800" kern="1200">
+                <a:solidFill>
+                  <a:schemeClr val="tx1"/>
+                </a:solidFill>
+                <a:latin typeface="+mn-lt"/>
+                <a:ea typeface="+mn-ea"/>
+                <a:cs typeface="+mn-cs"/>
+              </a:defRPr>
+            </a:lvl1pPr>
+            <a:lvl2pPr marL="685800" indent="-228600" algn="l" defTabSz="914400" rtl="0" eaLnBrk="1" latinLnBrk="0" hangingPunct="1">
+              <a:lnSpc>
+                <a:spcPct val="90000"/>
+              </a:lnSpc>
+              <a:spcBef>
+                <a:spcPts val="500"/>
+              </a:spcBef>
+              <a:buFont typeface="Arial" panose="020B0604020202020204" pitchFamily="34" charset="0"/>
+              <a:buChar char="•"/>
+              <a:defRPr sz="2400" kern="1200">
+                <a:solidFill>
+                  <a:schemeClr val="tx1"/>
+                </a:solidFill>
+                <a:latin typeface="+mn-lt"/>
+                <a:ea typeface="+mn-ea"/>
+                <a:cs typeface="+mn-cs"/>
+              </a:defRPr>
+            </a:lvl2pPr>
+            <a:lvl3pPr marL="1143000" indent="-228600" algn="l" defTabSz="914400" rtl="0" eaLnBrk="1" latinLnBrk="0" hangingPunct="1">
+              <a:lnSpc>
+                <a:spcPct val="90000"/>
+              </a:lnSpc>
+              <a:spcBef>
+                <a:spcPts val="500"/>
+              </a:spcBef>
+              <a:buFont typeface="Arial" panose="020B0604020202020204" pitchFamily="34" charset="0"/>
+              <a:buChar char="•"/>
+              <a:defRPr sz="2000" kern="1200">
+                <a:solidFill>
+                  <a:schemeClr val="tx1"/>
+                </a:solidFill>
+                <a:latin typeface="+mn-lt"/>
+                <a:ea typeface="+mn-ea"/>
+                <a:cs typeface="+mn-cs"/>
+              </a:defRPr>
+            </a:lvl3pPr>
+            <a:lvl4pPr marL="1600200" indent="-228600" algn="l" defTabSz="914400" rtl="0" eaLnBrk="1" latinLnBrk="0" hangingPunct="1">
+              <a:lnSpc>
+                <a:spcPct val="90000"/>
+              </a:lnSpc>
+              <a:spcBef>
+                <a:spcPts val="500"/>
+              </a:spcBef>
+              <a:buFont typeface="Arial" panose="020B0604020202020204" pitchFamily="34" charset="0"/>
+              <a:buChar char="•"/>
+              <a:defRPr sz="1800" kern="1200">
+                <a:solidFill>
+                  <a:schemeClr val="tx1"/>
+                </a:solidFill>
+                <a:latin typeface="+mn-lt"/>
+                <a:ea typeface="+mn-ea"/>
+                <a:cs typeface="+mn-cs"/>
+              </a:defRPr>
+            </a:lvl4pPr>
+            <a:lvl5pPr marL="2057400" indent="-228600" algn="l" defTabSz="914400" rtl="0" eaLnBrk="1" latinLnBrk="0" hangingPunct="1">
+              <a:lnSpc>
+                <a:spcPct val="90000"/>
+              </a:lnSpc>
+              <a:spcBef>
+                <a:spcPts val="500"/>
+              </a:spcBef>
+              <a:buFont typeface="Arial" panose="020B0604020202020204" pitchFamily="34" charset="0"/>
+              <a:buChar char="•"/>
+              <a:defRPr sz="1800" kern="1200">
+                <a:solidFill>
+                  <a:schemeClr val="tx1"/>
+                </a:solidFill>
+                <a:latin typeface="+mn-lt"/>
+                <a:ea typeface="+mn-ea"/>
+                <a:cs typeface="+mn-cs"/>
+              </a:defRPr>
+            </a:lvl5pPr>
+            <a:lvl6pPr marL="2514600" indent="-228600" algn="l" defTabSz="914400" rtl="0" eaLnBrk="1" latinLnBrk="0" hangingPunct="1">
+              <a:lnSpc>
+                <a:spcPct val="90000"/>
+              </a:lnSpc>
+              <a:spcBef>
+                <a:spcPts val="500"/>
+              </a:spcBef>
+              <a:buFont typeface="Arial" panose="020B0604020202020204" pitchFamily="34" charset="0"/>
+              <a:buChar char="•"/>
+              <a:defRPr sz="1800" kern="1200">
+                <a:solidFill>
+                  <a:schemeClr val="tx1"/>
+                </a:solidFill>
+                <a:latin typeface="+mn-lt"/>
+                <a:ea typeface="+mn-ea"/>
+                <a:cs typeface="+mn-cs"/>
+              </a:defRPr>
+            </a:lvl6pPr>
+            <a:lvl7pPr marL="2971800" indent="-228600" algn="l" defTabSz="914400" rtl="0" eaLnBrk="1" latinLnBrk="0" hangingPunct="1">
+              <a:lnSpc>
+                <a:spcPct val="90000"/>
+              </a:lnSpc>
+              <a:spcBef>
+                <a:spcPts val="500"/>
+              </a:spcBef>
+              <a:buFont typeface="Arial" panose="020B0604020202020204" pitchFamily="34" charset="0"/>
+              <a:buChar char="•"/>
+              <a:defRPr sz="1800" kern="1200">
+                <a:solidFill>
+                  <a:schemeClr val="tx1"/>
+                </a:solidFill>
+                <a:latin typeface="+mn-lt"/>
+                <a:ea typeface="+mn-ea"/>
+                <a:cs typeface="+mn-cs"/>
+              </a:defRPr>
+            </a:lvl7pPr>
+            <a:lvl8pPr marL="3429000" indent="-228600" algn="l" defTabSz="914400" rtl="0" eaLnBrk="1" latinLnBrk="0" hangingPunct="1">
+              <a:lnSpc>
+                <a:spcPct val="90000"/>
+              </a:lnSpc>
+              <a:spcBef>
+                <a:spcPts val="500"/>
+              </a:spcBef>
+              <a:buFont typeface="Arial" panose="020B0604020202020204" pitchFamily="34" charset="0"/>
+              <a:buChar char="•"/>
+              <a:defRPr sz="1800" kern="1200">
+                <a:solidFill>
+                  <a:schemeClr val="tx1"/>
+                </a:solidFill>
+                <a:latin typeface="+mn-lt"/>
+                <a:ea typeface="+mn-ea"/>
+                <a:cs typeface="+mn-cs"/>
+              </a:defRPr>
+            </a:lvl8pPr>
+            <a:lvl9pPr marL="3886200" indent="-228600" algn="l" defTabSz="914400" rtl="0" eaLnBrk="1" latinLnBrk="0" hangingPunct="1">
+              <a:lnSpc>
+                <a:spcPct val="90000"/>
+              </a:lnSpc>
+              <a:spcBef>
+                <a:spcPts val="500"/>
+              </a:spcBef>
+              <a:buFont typeface="Arial" panose="020B0604020202020204" pitchFamily="34" charset="0"/>
+              <a:buChar char="•"/>
+              <a:defRPr sz="1800" kern="1200">
+                <a:solidFill>
+                  <a:schemeClr val="tx1"/>
+                </a:solidFill>
+                <a:latin typeface="+mn-lt"/>
+                <a:ea typeface="+mn-ea"/>
+                <a:cs typeface="+mn-cs"/>
+              </a:defRPr>
+            </a:lvl9pPr>
+          </a:lstStyle>
+          <a:p>
+            <a:pPr marL="0" indent="0">
+              <a:buNone/>
+            </a:pPr>
+            <a:r>
+              <a:rPr lang="ru-RU" sz="2000" b="1" dirty="0"/>
+              <a:t>Не удалось достичь ускорения</a:t>
+            </a:r>
+          </a:p>
+          <a:p>
+            <a:pPr marL="0" indent="0">
+              <a:buNone/>
+            </a:pPr>
+            <a:r>
+              <a:rPr lang="ru-RU" sz="2000" dirty="0"/>
+              <a:t>Модель:</a:t>
+            </a:r>
+          </a:p>
+          <a:p>
+            <a:r>
+              <a:rPr lang="ru-RU" sz="2000" dirty="0"/>
+              <a:t>почти полностью состоит из Conv2d</a:t>
+            </a:r>
+          </a:p>
+          <a:p>
+            <a:r>
+              <a:rPr lang="ru-RU" sz="2000" dirty="0"/>
+              <a:t>не содержит тяжёлых </a:t>
+            </a:r>
+            <a:r>
+              <a:rPr lang="ru-RU" sz="2000" dirty="0" err="1"/>
+              <a:t>Linear</a:t>
+            </a:r>
+            <a:r>
+              <a:rPr lang="ru-RU" sz="2000" dirty="0"/>
+              <a:t>-слоёв</a:t>
+            </a:r>
+          </a:p>
+          <a:p>
+            <a:pPr marL="0" indent="0">
+              <a:buNone/>
+            </a:pPr>
+            <a:r>
+              <a:rPr lang="ru-RU" sz="2000" dirty="0"/>
+              <a:t>2:4 </a:t>
+            </a:r>
+            <a:r>
+              <a:rPr lang="ru-RU" sz="2000" dirty="0" err="1"/>
+              <a:t>sparsity</a:t>
+            </a:r>
+            <a:r>
+              <a:rPr lang="ru-RU" sz="2000" dirty="0"/>
+              <a:t> в </a:t>
+            </a:r>
+            <a:r>
+              <a:rPr lang="ru-RU" sz="2000" dirty="0" err="1"/>
+              <a:t>PyTorch</a:t>
+            </a:r>
+            <a:r>
+              <a:rPr lang="ru-RU" sz="2000" dirty="0"/>
+              <a:t>:</a:t>
+            </a:r>
+          </a:p>
+          <a:p>
+            <a:r>
+              <a:rPr lang="ru-RU" sz="2000" dirty="0"/>
+              <a:t>ускоряется через </a:t>
+            </a:r>
+            <a:r>
+              <a:rPr lang="ru-RU" sz="2000" dirty="0" err="1"/>
+              <a:t>sparse</a:t>
+            </a:r>
+            <a:r>
+              <a:rPr lang="ru-RU" sz="2000" dirty="0"/>
+              <a:t> </a:t>
+            </a:r>
+            <a:r>
+              <a:rPr lang="ru-RU" sz="2000" dirty="0" err="1"/>
+              <a:t>matmul</a:t>
+            </a:r>
+            <a:r>
+              <a:rPr lang="ru-RU" sz="2000" dirty="0"/>
+              <a:t> (GEMM)</a:t>
+            </a:r>
+          </a:p>
+          <a:p>
+            <a:r>
+              <a:rPr lang="ru-RU" sz="2000" dirty="0"/>
+              <a:t>эффективно работает для </a:t>
+            </a:r>
+            <a:r>
+              <a:rPr lang="ru-RU" sz="2000" dirty="0" err="1"/>
+              <a:t>nn.Linear</a:t>
+            </a:r>
+            <a:endParaRPr lang="ru-RU" sz="2000" dirty="0"/>
+          </a:p>
+          <a:p>
+            <a:r>
+              <a:rPr lang="ru-RU" sz="2000" dirty="0"/>
+              <a:t>не даёт ускорения для Conv2d (т.к. Conv2d + 2:4 </a:t>
+            </a:r>
+            <a:r>
+              <a:rPr lang="ru-RU" sz="2000" dirty="0" err="1"/>
+              <a:t>mask</a:t>
+            </a:r>
+            <a:r>
+              <a:rPr lang="ru-RU" sz="2000" dirty="0"/>
+              <a:t> -&gt; вычисляется как обычный </a:t>
+            </a:r>
+            <a:r>
+              <a:rPr lang="ru-RU" sz="2000" dirty="0" err="1"/>
+              <a:t>dense</a:t>
+            </a:r>
+            <a:r>
+              <a:rPr lang="ru-RU" sz="2000" dirty="0"/>
+              <a:t> </a:t>
+            </a:r>
+            <a:r>
+              <a:rPr lang="ru-RU" sz="2000" dirty="0" err="1"/>
+              <a:t>conv</a:t>
+            </a:r>
+            <a:r>
+              <a:rPr lang="ru-RU" sz="2000" dirty="0"/>
+              <a:t> с нулями)</a:t>
+            </a:r>
+          </a:p>
+          <a:p>
+            <a:pPr marL="0" indent="0">
+              <a:buNone/>
+            </a:pPr>
+            <a:endParaRPr lang="ru-RU" sz="2000" dirty="0"/>
+          </a:p>
+        </p:txBody>
+      </p:sp>
+    </p:spTree>
+    <p:extLst>
+      <p:ext uri="{BB962C8B-B14F-4D97-AF65-F5344CB8AC3E}">
+        <p14:creationId xmlns:p14="http://schemas.microsoft.com/office/powerpoint/2010/main" val="325205390"/>
       </p:ext>
     </p:extLst>
   </p:cSld>
@@ -20181,27 +20222,6 @@
               <a:rPr lang="en" sz="2000" b="1" dirty="0">
                 <a:latin typeface="Maven Pro" panose="00000500000000000000" pitchFamily="2" charset="0"/>
               </a:rPr>
-              <a:t>Model trained parameters: </a:t>
-            </a:r>
-            <a:r>
-              <a:rPr lang="en" sz="2000" dirty="0">
-                <a:latin typeface="Maven Pro" panose="00000500000000000000" pitchFamily="2" charset="0"/>
-              </a:rPr>
-              <a:t>9 024 673</a:t>
-            </a:r>
-          </a:p>
-          <a:p>
-            <a:pPr marL="228594" indent="-228594">
-              <a:lnSpc>
-                <a:spcPct val="150000"/>
-              </a:lnSpc>
-              <a:buFont typeface="Arial"/>
-              <a:buChar char="•"/>
-            </a:pPr>
-            <a:r>
-              <a:rPr lang="en" sz="2000" b="1" dirty="0">
-                <a:latin typeface="Maven Pro" panose="00000500000000000000" pitchFamily="2" charset="0"/>
-              </a:rPr>
               <a:t>Train decoder dataset: </a:t>
             </a:r>
             <a:r>
@@ -20220,6 +20240,66 @@
               <a:buChar char="•"/>
             </a:pPr>
             <a:r>
+              <a:rPr lang="en" sz="2000" b="1" dirty="0">
+                <a:latin typeface="Maven Pro" panose="00000500000000000000" pitchFamily="2" charset="0"/>
+              </a:rPr>
+              <a:t>Dataset size: </a:t>
+            </a:r>
+            <a:r>
+              <a:rPr lang="en-US" sz="2000" dirty="0">
+                <a:latin typeface="Maven Pro" panose="00000500000000000000" pitchFamily="2" charset="0"/>
+              </a:rPr>
+              <a:t>~ 123 000 images</a:t>
+            </a:r>
+          </a:p>
+          <a:p>
+            <a:pPr marL="228594" indent="-228594">
+              <a:lnSpc>
+                <a:spcPct val="150000"/>
+              </a:lnSpc>
+              <a:buFont typeface="Arial"/>
+              <a:buChar char="•"/>
+            </a:pPr>
+            <a:r>
+              <a:rPr lang="en" sz="2000" b="1" dirty="0">
+                <a:latin typeface="Maven Pro" panose="00000500000000000000" pitchFamily="2" charset="0"/>
+              </a:rPr>
+              <a:t>Number</a:t>
+            </a:r>
+            <a:r>
+              <a:rPr lang="ru-RU" sz="2000" b="1" dirty="0">
+                <a:latin typeface="Maven Pro" panose="00000500000000000000" pitchFamily="2" charset="0"/>
+              </a:rPr>
+              <a:t> </a:t>
+            </a:r>
+            <a:r>
+              <a:rPr lang="en-US" sz="2000" b="1" dirty="0">
+                <a:latin typeface="Maven Pro" panose="00000500000000000000" pitchFamily="2" charset="0"/>
+              </a:rPr>
+              <a:t>of</a:t>
+            </a:r>
+            <a:r>
+              <a:rPr lang="en" sz="2000" b="1" dirty="0">
+                <a:latin typeface="Maven Pro" panose="00000500000000000000" pitchFamily="2" charset="0"/>
+              </a:rPr>
+              <a:t> classes: </a:t>
+            </a:r>
+            <a:r>
+              <a:rPr lang="en" sz="2000" dirty="0">
+                <a:latin typeface="Maven Pro" panose="00000500000000000000" pitchFamily="2" charset="0"/>
+              </a:rPr>
+              <a:t>81</a:t>
+            </a:r>
+          </a:p>
+          <a:p>
+            <a:pPr marL="228594" indent="-228594">
+              <a:lnSpc>
+                <a:spcPct val="150000"/>
+              </a:lnSpc>
+              <a:buFont typeface="Arial"/>
+              <a:buChar char="•"/>
+            </a:pPr>
+            <a:r>
               <a:rPr lang="en-US" sz="2000" b="1" dirty="0">
                 <a:latin typeface="Maven Pro" panose="00000500000000000000" pitchFamily="2" charset="0"/>
               </a:rPr>
@@ -20232,11 +20312,14 @@
               <a:t>type: </a:t>
             </a:r>
             <a:r>
-              <a:rPr lang="en" sz="2000" dirty="0">
+              <a:rPr lang="en-US" sz="2000" dirty="0">
                 <a:latin typeface="Maven Pro" panose="00000500000000000000" pitchFamily="2" charset="0"/>
               </a:rPr>
-              <a:t>float32</a:t>
-            </a:r>
+              <a:t>bfloat16</a:t>
+            </a:r>
+            <a:endParaRPr lang="en" sz="2000" dirty="0">
+              <a:latin typeface="Maven Pro" panose="00000500000000000000" pitchFamily="2" charset="0"/>
+            </a:endParaRPr>
           </a:p>
         </p:txBody>
       </p:sp>

</xml_diff>

<commit_message>
final version without quantization
</commit_message>
<xml_diff>
--- a/unet_inference_240426.pptx
+++ b/unet_inference_240426.pptx
@@ -18892,10 +18892,10 @@
       </p:sp>
       <p:pic>
         <p:nvPicPr>
-          <p:cNvPr id="2" name="Рисунок 1">
+          <p:cNvPr id="4" name="Рисунок 3">
             <a:extLst>
               <a:ext uri="{FF2B5EF4-FFF2-40B4-BE49-F238E27FC236}">
-                <a16:creationId xmlns:a16="http://schemas.microsoft.com/office/drawing/2014/main" id="{CA5926D9-C71E-DDB5-5C20-E3F91F17BD95}"/>
+                <a16:creationId xmlns:a16="http://schemas.microsoft.com/office/drawing/2014/main" id="{B78FF8A2-6B28-852D-FDFC-9942AB1BBBE1}"/>
               </a:ext>
             </a:extLst>
           </p:cNvPr>
@@ -18912,8 +18912,8 @@
         </p:blipFill>
         <p:spPr>
           <a:xfrm>
-            <a:off x="6126886" y="1905001"/>
-            <a:ext cx="5214578" cy="3846950"/>
+            <a:off x="580808" y="2047874"/>
+            <a:ext cx="5277704" cy="3704077"/>
           </a:xfrm>
           <a:prstGeom prst="rect">
             <a:avLst/>
@@ -18922,10 +18922,10 @@
       </p:pic>
       <p:pic>
         <p:nvPicPr>
-          <p:cNvPr id="4" name="Рисунок 3">
+          <p:cNvPr id="6" name="Рисунок 5">
             <a:extLst>
               <a:ext uri="{FF2B5EF4-FFF2-40B4-BE49-F238E27FC236}">
-                <a16:creationId xmlns:a16="http://schemas.microsoft.com/office/drawing/2014/main" id="{B78FF8A2-6B28-852D-FDFC-9942AB1BBBE1}"/>
+                <a16:creationId xmlns:a16="http://schemas.microsoft.com/office/drawing/2014/main" id="{DF6E47BE-B841-C4E1-48FF-DFB00526B322}"/>
               </a:ext>
             </a:extLst>
           </p:cNvPr>
@@ -18935,15 +18935,21 @@
           <p:nvPr/>
         </p:nvPicPr>
         <p:blipFill>
-          <a:blip r:embed="rId4"/>
+          <a:blip r:embed="rId4" cstate="print">
+            <a:extLst>
+              <a:ext uri="{28A0092B-C50C-407E-A947-70E740481C1C}">
+                <a14:useLocalDpi xmlns:a14="http://schemas.microsoft.com/office/drawing/2010/main" val="0"/>
+              </a:ext>
+            </a:extLst>
+          </a:blip>
           <a:stretch>
             <a:fillRect/>
           </a:stretch>
         </p:blipFill>
         <p:spPr>
           <a:xfrm>
-            <a:off x="580808" y="2047874"/>
-            <a:ext cx="5277704" cy="3704077"/>
+            <a:off x="6333490" y="1986775"/>
+            <a:ext cx="5120640" cy="3765176"/>
           </a:xfrm>
           <a:prstGeom prst="rect">
             <a:avLst/>

</xml_diff>